<commit_message>
Update v5.4 report with SS/GY split and Victor follow-up; add renumbered files and icon deck
Documents the completed group split, renumbered Spanish Supplement/German
Youth files prepared for Victor, and adds the updated HymnIcons.pptx with
the new SS/GY icon designs.

Co-Authored-By: Claude Sonnet 5 <noreply@anthropic.com>
Claude-Session: https://claude.ai/code/session_01XqeEY3arQUikECfmns7rj7
</commit_message>
<xml_diff>
--- a/docs/HymnIcons.pptx
+++ b/docs/HymnIcons.pptx
@@ -214,7 +214,7 @@
           <a:p>
             <a:fld id="{EF9CD902-8637-1048-BDEB-F124F7F64116}" type="datetimeFigureOut">
               <a:rPr lang="en-US" smtClean="0"/>
-              <a:t>5/21/2026</a:t>
+              <a:t>9/2/2026</a:t>
             </a:fld>
             <a:endParaRPr lang="en-US"/>
           </a:p>
@@ -744,7 +744,7 @@
           <a:p>
             <a:fld id="{477B3B45-EB55-46BF-8EE7-F91257854600}" type="datetimeFigureOut">
               <a:rPr lang="en-US" smtClean="0"/>
-              <a:t>5/21/2026</a:t>
+              <a:t>9/2/2026</a:t>
             </a:fld>
             <a:endParaRPr lang="en-US"/>
           </a:p>
@@ -907,7 +907,7 @@
           <a:p>
             <a:fld id="{477B3B45-EB55-46BF-8EE7-F91257854600}" type="datetimeFigureOut">
               <a:rPr lang="en-US" smtClean="0"/>
-              <a:t>5/21/2026</a:t>
+              <a:t>9/2/2026</a:t>
             </a:fld>
             <a:endParaRPr lang="en-US"/>
           </a:p>
@@ -1080,7 +1080,7 @@
           <a:p>
             <a:fld id="{477B3B45-EB55-46BF-8EE7-F91257854600}" type="datetimeFigureOut">
               <a:rPr lang="en-US" smtClean="0"/>
-              <a:t>5/21/2026</a:t>
+              <a:t>9/2/2026</a:t>
             </a:fld>
             <a:endParaRPr lang="en-US"/>
           </a:p>
@@ -1243,7 +1243,7 @@
           <a:p>
             <a:fld id="{477B3B45-EB55-46BF-8EE7-F91257854600}" type="datetimeFigureOut">
               <a:rPr lang="en-US" smtClean="0"/>
-              <a:t>5/21/2026</a:t>
+              <a:t>9/2/2026</a:t>
             </a:fld>
             <a:endParaRPr lang="en-US"/>
           </a:p>
@@ -1483,7 +1483,7 @@
           <a:p>
             <a:fld id="{477B3B45-EB55-46BF-8EE7-F91257854600}" type="datetimeFigureOut">
               <a:rPr lang="en-US" smtClean="0"/>
-              <a:t>5/21/2026</a:t>
+              <a:t>9/2/2026</a:t>
             </a:fld>
             <a:endParaRPr lang="en-US"/>
           </a:p>
@@ -1763,7 +1763,7 @@
           <a:p>
             <a:fld id="{477B3B45-EB55-46BF-8EE7-F91257854600}" type="datetimeFigureOut">
               <a:rPr lang="en-US" smtClean="0"/>
-              <a:t>5/21/2026</a:t>
+              <a:t>9/2/2026</a:t>
             </a:fld>
             <a:endParaRPr lang="en-US"/>
           </a:p>
@@ -2177,7 +2177,7 @@
           <a:p>
             <a:fld id="{477B3B45-EB55-46BF-8EE7-F91257854600}" type="datetimeFigureOut">
               <a:rPr lang="en-US" smtClean="0"/>
-              <a:t>5/21/2026</a:t>
+              <a:t>9/2/2026</a:t>
             </a:fld>
             <a:endParaRPr lang="en-US"/>
           </a:p>
@@ -2289,7 +2289,7 @@
           <a:p>
             <a:fld id="{477B3B45-EB55-46BF-8EE7-F91257854600}" type="datetimeFigureOut">
               <a:rPr lang="en-US" smtClean="0"/>
-              <a:t>5/21/2026</a:t>
+              <a:t>9/2/2026</a:t>
             </a:fld>
             <a:endParaRPr lang="en-US"/>
           </a:p>
@@ -2379,7 +2379,7 @@
           <a:p>
             <a:fld id="{477B3B45-EB55-46BF-8EE7-F91257854600}" type="datetimeFigureOut">
               <a:rPr lang="en-US" smtClean="0"/>
-              <a:t>5/21/2026</a:t>
+              <a:t>9/2/2026</a:t>
             </a:fld>
             <a:endParaRPr lang="en-US"/>
           </a:p>
@@ -2649,7 +2649,7 @@
           <a:p>
             <a:fld id="{477B3B45-EB55-46BF-8EE7-F91257854600}" type="datetimeFigureOut">
               <a:rPr lang="en-US" smtClean="0"/>
-              <a:t>5/21/2026</a:t>
+              <a:t>9/2/2026</a:t>
             </a:fld>
             <a:endParaRPr lang="en-US"/>
           </a:p>
@@ -2896,7 +2896,7 @@
           <a:p>
             <a:fld id="{477B3B45-EB55-46BF-8EE7-F91257854600}" type="datetimeFigureOut">
               <a:rPr lang="en-US" smtClean="0"/>
-              <a:t>5/21/2026</a:t>
+              <a:t>9/2/2026</a:t>
             </a:fld>
             <a:endParaRPr lang="en-US"/>
           </a:p>
@@ -3102,7 +3102,7 @@
           <a:p>
             <a:fld id="{477B3B45-EB55-46BF-8EE7-F91257854600}" type="datetimeFigureOut">
               <a:rPr lang="en-US" smtClean="0"/>
-              <a:t>5/21/2026</a:t>
+              <a:t>9/2/2026</a:t>
             </a:fld>
             <a:endParaRPr lang="en-US"/>
           </a:p>
@@ -4438,6 +4438,70 @@
           </a:p>
         </p:txBody>
       </p:sp>
+      <p:sp>
+        <p:nvSpPr>
+          <p:cNvPr id="2" name="Rounded Rectangle 5">
+            <a:extLst>
+              <a:ext uri="{FF2B5EF4-FFF2-40B4-BE49-F238E27FC236}">
+                <a16:creationId xmlns:a16="http://schemas.microsoft.com/office/drawing/2014/main" id="{E4A5F93E-4DD3-AFC8-AA8E-0BC75F96F139}"/>
+              </a:ext>
+            </a:extLst>
+          </p:cNvPr>
+          <p:cNvSpPr/>
+          <p:nvPr/>
+        </p:nvSpPr>
+        <p:spPr>
+          <a:xfrm>
+            <a:off x="2362200" y="4195465"/>
+            <a:ext cx="2057400" cy="2057400"/>
+          </a:xfrm>
+          <a:prstGeom prst="roundRect">
+            <a:avLst/>
+          </a:prstGeom>
+          <a:solidFill>
+            <a:srgbClr val="7986CB"/>
+          </a:solidFill>
+          <a:ln w="76200">
+            <a:solidFill>
+              <a:srgbClr val="3F51B5"/>
+            </a:solidFill>
+          </a:ln>
+        </p:spPr>
+        <p:style>
+          <a:lnRef idx="1">
+            <a:schemeClr val="dk1"/>
+          </a:lnRef>
+          <a:fillRef idx="2">
+            <a:schemeClr val="dk1"/>
+          </a:fillRef>
+          <a:effectRef idx="1">
+            <a:schemeClr val="dk1"/>
+          </a:effectRef>
+          <a:fontRef idx="minor">
+            <a:schemeClr val="dk1"/>
+          </a:fontRef>
+        </p:style>
+        <p:txBody>
+          <a:bodyPr rtlCol="0" anchor="ctr">
+            <a:normAutofit/>
+          </a:bodyPr>
+          <a:lstStyle/>
+          <a:p>
+            <a:pPr algn="ctr"/>
+            <a:r>
+              <a:rPr lang="en-US" sz="9600" dirty="0">
+                <a:solidFill>
+                  <a:schemeClr val="bg1">
+                    <a:lumMod val="95000"/>
+                  </a:schemeClr>
+                </a:solidFill>
+                <a:latin typeface="Century" pitchFamily="18" charset="0"/>
+              </a:rPr>
+              <a:t>SS</a:t>
+            </a:r>
+          </a:p>
+        </p:txBody>
+      </p:sp>
     </p:spTree>
     <p:extLst>
       <p:ext uri="{BB962C8B-B14F-4D97-AF65-F5344CB8AC3E}">
@@ -4795,6 +4859,70 @@
             <a:r>
               <a:rPr lang="en-US" dirty="0"/>
               <a:t>500 - 00BCD4</a:t>
+            </a:r>
+          </a:p>
+        </p:txBody>
+      </p:sp>
+      <p:sp>
+        <p:nvSpPr>
+          <p:cNvPr id="8" name="Rounded Rectangle 3">
+            <a:extLst>
+              <a:ext uri="{FF2B5EF4-FFF2-40B4-BE49-F238E27FC236}">
+                <a16:creationId xmlns:a16="http://schemas.microsoft.com/office/drawing/2014/main" id="{43FDE1ED-1EF0-B8C4-9472-5F5F01D950F6}"/>
+              </a:ext>
+            </a:extLst>
+          </p:cNvPr>
+          <p:cNvSpPr/>
+          <p:nvPr/>
+        </p:nvSpPr>
+        <p:spPr>
+          <a:xfrm>
+            <a:off x="1905000" y="3962400"/>
+            <a:ext cx="2057400" cy="2057400"/>
+          </a:xfrm>
+          <a:prstGeom prst="roundRect">
+            <a:avLst/>
+          </a:prstGeom>
+          <a:solidFill>
+            <a:srgbClr val="FF8A65"/>
+          </a:solidFill>
+          <a:ln w="76200">
+            <a:solidFill>
+              <a:srgbClr val="FF5722"/>
+            </a:solidFill>
+          </a:ln>
+        </p:spPr>
+        <p:style>
+          <a:lnRef idx="1">
+            <a:schemeClr val="dk1"/>
+          </a:lnRef>
+          <a:fillRef idx="2">
+            <a:schemeClr val="dk1"/>
+          </a:fillRef>
+          <a:effectRef idx="1">
+            <a:schemeClr val="dk1"/>
+          </a:effectRef>
+          <a:fontRef idx="minor">
+            <a:schemeClr val="dk1"/>
+          </a:fontRef>
+        </p:style>
+        <p:txBody>
+          <a:bodyPr rtlCol="0" anchor="ctr">
+            <a:normAutofit fontScale="85000" lnSpcReduction="10000"/>
+          </a:bodyPr>
+          <a:lstStyle/>
+          <a:p>
+            <a:pPr algn="ctr"/>
+            <a:r>
+              <a:rPr lang="en-US" sz="9600" dirty="0">
+                <a:solidFill>
+                  <a:schemeClr val="bg1">
+                    <a:lumMod val="95000"/>
+                  </a:schemeClr>
+                </a:solidFill>
+                <a:latin typeface="Century" pitchFamily="18" charset="0"/>
+              </a:rPr>
+              <a:t>GY</a:t>
             </a:r>
           </a:p>
         </p:txBody>

</xml_diff>

<commit_message>
Add Spanish Youth (SY) icon design to HymnIcons.pptx
Co-Authored-By: Claude Sonnet 5 <noreply@anthropic.com>
Claude-Session: https://claude.ai/code/session_019bzJQ41AQXN8KfiTR5jtUD
</commit_message>
<xml_diff>
--- a/docs/HymnIcons.pptx
+++ b/docs/HymnIcons.pptx
@@ -214,7 +214,7 @@
           <a:p>
             <a:fld id="{EF9CD902-8637-1048-BDEB-F124F7F64116}" type="datetimeFigureOut">
               <a:rPr lang="en-US" smtClean="0"/>
-              <a:t>9/2/2026</a:t>
+              <a:t>9/11/2026</a:t>
             </a:fld>
             <a:endParaRPr lang="en-US"/>
           </a:p>
@@ -744,7 +744,7 @@
           <a:p>
             <a:fld id="{477B3B45-EB55-46BF-8EE7-F91257854600}" type="datetimeFigureOut">
               <a:rPr lang="en-US" smtClean="0"/>
-              <a:t>9/2/2026</a:t>
+              <a:t>9/11/2026</a:t>
             </a:fld>
             <a:endParaRPr lang="en-US"/>
           </a:p>
@@ -907,7 +907,7 @@
           <a:p>
             <a:fld id="{477B3B45-EB55-46BF-8EE7-F91257854600}" type="datetimeFigureOut">
               <a:rPr lang="en-US" smtClean="0"/>
-              <a:t>9/2/2026</a:t>
+              <a:t>9/11/2026</a:t>
             </a:fld>
             <a:endParaRPr lang="en-US"/>
           </a:p>
@@ -1080,7 +1080,7 @@
           <a:p>
             <a:fld id="{477B3B45-EB55-46BF-8EE7-F91257854600}" type="datetimeFigureOut">
               <a:rPr lang="en-US" smtClean="0"/>
-              <a:t>9/2/2026</a:t>
+              <a:t>9/11/2026</a:t>
             </a:fld>
             <a:endParaRPr lang="en-US"/>
           </a:p>
@@ -1243,7 +1243,7 @@
           <a:p>
             <a:fld id="{477B3B45-EB55-46BF-8EE7-F91257854600}" type="datetimeFigureOut">
               <a:rPr lang="en-US" smtClean="0"/>
-              <a:t>9/2/2026</a:t>
+              <a:t>9/11/2026</a:t>
             </a:fld>
             <a:endParaRPr lang="en-US"/>
           </a:p>
@@ -1483,7 +1483,7 @@
           <a:p>
             <a:fld id="{477B3B45-EB55-46BF-8EE7-F91257854600}" type="datetimeFigureOut">
               <a:rPr lang="en-US" smtClean="0"/>
-              <a:t>9/2/2026</a:t>
+              <a:t>9/11/2026</a:t>
             </a:fld>
             <a:endParaRPr lang="en-US"/>
           </a:p>
@@ -1763,7 +1763,7 @@
           <a:p>
             <a:fld id="{477B3B45-EB55-46BF-8EE7-F91257854600}" type="datetimeFigureOut">
               <a:rPr lang="en-US" smtClean="0"/>
-              <a:t>9/2/2026</a:t>
+              <a:t>9/11/2026</a:t>
             </a:fld>
             <a:endParaRPr lang="en-US"/>
           </a:p>
@@ -2177,7 +2177,7 @@
           <a:p>
             <a:fld id="{477B3B45-EB55-46BF-8EE7-F91257854600}" type="datetimeFigureOut">
               <a:rPr lang="en-US" smtClean="0"/>
-              <a:t>9/2/2026</a:t>
+              <a:t>9/11/2026</a:t>
             </a:fld>
             <a:endParaRPr lang="en-US"/>
           </a:p>
@@ -2289,7 +2289,7 @@
           <a:p>
             <a:fld id="{477B3B45-EB55-46BF-8EE7-F91257854600}" type="datetimeFigureOut">
               <a:rPr lang="en-US" smtClean="0"/>
-              <a:t>9/2/2026</a:t>
+              <a:t>9/11/2026</a:t>
             </a:fld>
             <a:endParaRPr lang="en-US"/>
           </a:p>
@@ -2379,7 +2379,7 @@
           <a:p>
             <a:fld id="{477B3B45-EB55-46BF-8EE7-F91257854600}" type="datetimeFigureOut">
               <a:rPr lang="en-US" smtClean="0"/>
-              <a:t>9/2/2026</a:t>
+              <a:t>9/11/2026</a:t>
             </a:fld>
             <a:endParaRPr lang="en-US"/>
           </a:p>
@@ -2649,7 +2649,7 @@
           <a:p>
             <a:fld id="{477B3B45-EB55-46BF-8EE7-F91257854600}" type="datetimeFigureOut">
               <a:rPr lang="en-US" smtClean="0"/>
-              <a:t>9/2/2026</a:t>
+              <a:t>9/11/2026</a:t>
             </a:fld>
             <a:endParaRPr lang="en-US"/>
           </a:p>
@@ -2896,7 +2896,7 @@
           <a:p>
             <a:fld id="{477B3B45-EB55-46BF-8EE7-F91257854600}" type="datetimeFigureOut">
               <a:rPr lang="en-US" smtClean="0"/>
-              <a:t>9/2/2026</a:t>
+              <a:t>9/11/2026</a:t>
             </a:fld>
             <a:endParaRPr lang="en-US"/>
           </a:p>
@@ -3102,7 +3102,7 @@
           <a:p>
             <a:fld id="{477B3B45-EB55-46BF-8EE7-F91257854600}" type="datetimeFigureOut">
               <a:rPr lang="en-US" smtClean="0"/>
-              <a:t>9/2/2026</a:t>
+              <a:t>9/11/2026</a:t>
             </a:fld>
             <a:endParaRPr lang="en-US"/>
           </a:p>
@@ -4497,7 +4497,7 @@
                 </a:solidFill>
                 <a:latin typeface="Century" pitchFamily="18" charset="0"/>
               </a:rPr>
-              <a:t>SS</a:t>
+              <a:t>SY</a:t>
             </a:r>
           </a:p>
         </p:txBody>

</xml_diff>